<commit_message>
Update install instructions to use native installer instead of npm
Co-Authored-By: Claude Opus 4.6 (1M context) <noreply@anthropic.com>
</commit_message>
<xml_diff>
--- a/ClaudeCodeWorkshop.pptx
+++ b/ClaudeCodeWorkshop.pptx
@@ -8,6 +8,7 @@
     <p:sldId id="262" r:id="rId5"/>
     <p:sldId id="261" r:id="rId6"/>
     <p:sldId id="268" r:id="rId7"/>
+    <p:sldId id="273" r:id="rId8"/>
   </p:sldIdLst>
   <p:sldSz cx="12192000" cy="6858000"/>
   <p:notesSz cx="6858000" cy="9144000"/>
@@ -112,14 +113,6 @@
     </p:ext>
   </p:extLst>
 </p:presentation>
-</file>
-
-<file path=ppt/revisionInfo.xml><?xml version="1.0" encoding="utf-8"?>
-<p1510:revInfo xmlns:a="http://schemas.openxmlformats.org/drawingml/2006/main" xmlns:r="http://schemas.openxmlformats.org/officeDocument/2006/relationships" xmlns:p1510="http://schemas.microsoft.com/office/powerpoint/2015/10/main">
-  <p1510:revLst>
-    <p1510:client id="{9C27275A-5004-4488-BB2B-8541C3EB84DB}" v="6" dt="2018-08-08T09:05:58.341"/>
-  </p1510:revLst>
-</p1510:revInfo>
 </file>
 
 <file path=ppt/slideLayouts/slideLayout1.xml><?xml version="1.0" encoding="utf-8"?>
@@ -5614,6 +5607,697 @@
     <p:extLst>
       <p:ext uri="{BB962C8B-B14F-4D97-AF65-F5344CB8AC3E}">
         <p14:creationId xmlns:p14="http://schemas.microsoft.com/office/powerpoint/2010/main" val="3465505839"/>
+      </p:ext>
+    </p:extLst>
+  </p:cSld>
+  <p:clrMapOvr>
+    <a:masterClrMapping/>
+  </p:clrMapOvr>
+</p:sld>
+</file>
+
+<file path=ppt/slides/slide4.xml><?xml version="1.0" encoding="utf-8"?>
+<p:sld xmlns:a="http://schemas.openxmlformats.org/drawingml/2006/main" xmlns:r="http://schemas.openxmlformats.org/officeDocument/2006/relationships" xmlns:p="http://schemas.openxmlformats.org/presentationml/2006/main">
+  <p:cSld>
+    <p:spTree>
+      <p:nvGrpSpPr>
+        <p:cNvPr id="1" name=""/>
+        <p:cNvGrpSpPr/>
+        <p:nvPr/>
+      </p:nvGrpSpPr>
+      <p:grpSpPr>
+        <a:xfrm>
+          <a:off x="0" y="0"/>
+          <a:ext cx="0" cy="0"/>
+          <a:chOff x="0" y="0"/>
+          <a:chExt cx="0" cy="0"/>
+        </a:xfrm>
+      </p:grpSpPr>
+      <p:sp>
+        <p:nvSpPr>
+          <p:cNvPr id="2" name="Title 1">
+            <a:extLst>
+              <a:ext uri="{FF2B5EF4-FFF2-40B4-BE49-F238E27FC236}">
+                <a16:creationId xmlns:a16="http://schemas.microsoft.com/office/drawing/2014/main" id="{0EE87B86-D0FF-6E91-8F5A-9C75E4542553}"/>
+              </a:ext>
+            </a:extLst>
+          </p:cNvPr>
+          <p:cNvSpPr>
+            <a:spLocks noGrp="1"/>
+          </p:cNvSpPr>
+          <p:nvPr>
+            <p:ph type="title"/>
+          </p:nvPr>
+        </p:nvSpPr>
+        <p:spPr>
+          <a:xfrm>
+            <a:off x="508000" y="317500"/>
+            <a:ext cx="11176000" cy="698500"/>
+          </a:xfrm>
+        </p:spPr>
+        <p:txBody>
+          <a:bodyPr>
+            <a:noAutofit/>
+          </a:bodyPr>
+          <a:lstStyle/>
+          <a:p>
+            <a:r>
+              <a:rPr lang="en-US" sz="3200"/>
+              <a:t>The Agent Loop</a:t>
+            </a:r>
+          </a:p>
+        </p:txBody>
+      </p:sp>
+      <p:sp>
+        <p:nvSpPr>
+          <p:cNvPr id="100" name="Context"/>
+          <p:cNvSpPr/>
+          <p:nvPr/>
+        </p:nvSpPr>
+        <p:spPr>
+          <a:xfrm>
+            <a:off x="2596000" y="1700000"/>
+            <a:ext cx="2000000" cy="1100000"/>
+          </a:xfrm>
+          <a:prstGeom prst="roundRect">
+            <a:avLst>
+              <a:gd name="adj" fmla="val 12000"/>
+            </a:avLst>
+          </a:prstGeom>
+          <a:solidFill>
+            <a:srgbClr val="2563EB"/>
+          </a:solidFill>
+          <a:ln>
+            <a:noFill/>
+          </a:ln>
+        </p:spPr>
+        <p:txBody>
+          <a:bodyPr wrap="square" lIns="36000" tIns="36000" rIns="36000" bIns="36000" anchor="ctr"/>
+          <a:lstStyle/>
+          <a:p>
+            <a:pPr algn="ctr">
+              <a:lnSpc>
+                <a:spcPts val="2000"/>
+              </a:lnSpc>
+              <a:buNone/>
+            </a:pPr>
+            <a:r>
+              <a:rPr lang="en-US" sz="1800" b="1" dirty="0">
+                <a:solidFill>
+                  <a:srgbClr val="FFFFFF"/>
+                </a:solidFill>
+                <a:latin typeface="Segoe UI Semibold"/>
+              </a:rPr>
+              <a:t>Context</a:t>
+            </a:r>
+          </a:p>
+          <a:p>
+            <a:pPr algn="ctr">
+              <a:lnSpc>
+                <a:spcPts val="1600"/>
+              </a:lnSpc>
+              <a:spcBef>
+                <a:spcPts val="100"/>
+              </a:spcBef>
+              <a:buNone/>
+            </a:pPr>
+            <a:r>
+              <a:rPr lang="en-US" sz="1200" dirty="0">
+                <a:solidFill>
+                  <a:srgbClr val="FFFFFF"/>
+                </a:solidFill>
+                <a:latin typeface="Segoe UI"/>
+              </a:rPr>
+              <a:t>+ tools, history</a:t>
+            </a:r>
+          </a:p>
+        </p:txBody>
+      </p:sp>
+      <p:sp>
+        <p:nvSpPr>
+          <p:cNvPr id="101" name="LLM"/>
+          <p:cNvSpPr/>
+          <p:nvPr/>
+        </p:nvSpPr>
+        <p:spPr>
+          <a:xfrm>
+            <a:off x="5096000" y="1700000"/>
+            <a:ext cx="2000000" cy="1100000"/>
+          </a:xfrm>
+          <a:prstGeom prst="roundRect">
+            <a:avLst>
+              <a:gd name="adj" fmla="val 12000"/>
+            </a:avLst>
+          </a:prstGeom>
+          <a:solidFill>
+            <a:srgbClr val="1A1A2E"/>
+          </a:solidFill>
+          <a:ln>
+            <a:noFill/>
+          </a:ln>
+        </p:spPr>
+        <p:txBody>
+          <a:bodyPr wrap="square" lIns="36000" tIns="36000" rIns="36000" bIns="36000" anchor="ctr"/>
+          <a:lstStyle/>
+          <a:p>
+            <a:pPr algn="ctr">
+              <a:lnSpc>
+                <a:spcPts val="2000"/>
+              </a:lnSpc>
+              <a:buNone/>
+            </a:pPr>
+            <a:r>
+              <a:rPr lang="en-US" sz="1800" b="1" dirty="0">
+                <a:solidFill>
+                  <a:srgbClr val="FFFFFF"/>
+                </a:solidFill>
+                <a:latin typeface="Segoe UI Semibold"/>
+              </a:rPr>
+              <a:t>LLM</a:t>
+            </a:r>
+          </a:p>
+          <a:p>
+            <a:pPr algn="ctr">
+              <a:lnSpc>
+                <a:spcPts val="1600"/>
+              </a:lnSpc>
+              <a:spcBef>
+                <a:spcPts val="100"/>
+              </a:spcBef>
+              <a:buNone/>
+            </a:pPr>
+            <a:r>
+              <a:rPr lang="en-US" sz="1200" dirty="0">
+                <a:solidFill>
+                  <a:srgbClr val="FFFFFF"/>
+                </a:solidFill>
+                <a:latin typeface="Segoe UI"/>
+              </a:rPr>
+              <a:t>Claude thinks...</a:t>
+            </a:r>
+          </a:p>
+        </p:txBody>
+      </p:sp>
+      <p:sp>
+        <p:nvSpPr>
+          <p:cNvPr id="102" name="Action"/>
+          <p:cNvSpPr/>
+          <p:nvPr/>
+        </p:nvSpPr>
+        <p:spPr>
+          <a:xfrm>
+            <a:off x="7596000" y="1700000"/>
+            <a:ext cx="2000000" cy="1100000"/>
+          </a:xfrm>
+          <a:prstGeom prst="roundRect">
+            <a:avLst>
+              <a:gd name="adj" fmla="val 12000"/>
+            </a:avLst>
+          </a:prstGeom>
+          <a:solidFill>
+            <a:srgbClr val="D97706"/>
+          </a:solidFill>
+          <a:ln>
+            <a:noFill/>
+          </a:ln>
+        </p:spPr>
+        <p:txBody>
+          <a:bodyPr wrap="square" lIns="36000" tIns="36000" rIns="36000" bIns="36000" anchor="ctr"/>
+          <a:lstStyle/>
+          <a:p>
+            <a:pPr algn="ctr">
+              <a:lnSpc>
+                <a:spcPts val="2000"/>
+              </a:lnSpc>
+              <a:buNone/>
+            </a:pPr>
+            <a:r>
+              <a:rPr lang="en-US" sz="1800" b="1" dirty="0">
+                <a:solidFill>
+                  <a:srgbClr val="FFFFFF"/>
+                </a:solidFill>
+                <a:latin typeface="Segoe UI Semibold"/>
+              </a:rPr>
+              <a:t>Action</a:t>
+            </a:r>
+          </a:p>
+          <a:p>
+            <a:pPr algn="ctr">
+              <a:lnSpc>
+                <a:spcPts val="1600"/>
+              </a:lnSpc>
+              <a:spcBef>
+                <a:spcPts val="100"/>
+              </a:spcBef>
+              <a:buNone/>
+            </a:pPr>
+            <a:r>
+              <a:rPr lang="en-US" sz="1200" dirty="0">
+                <a:solidFill>
+                  <a:srgbClr val="FFFFFF"/>
+                </a:solidFill>
+                <a:latin typeface="Segoe UI"/>
+              </a:rPr>
+              <a:t>edit file, run cmd</a:t>
+            </a:r>
+          </a:p>
+        </p:txBody>
+      </p:sp>
+      <p:sp>
+        <p:nvSpPr>
+          <p:cNvPr id="103" name="Response"/>
+          <p:cNvSpPr/>
+          <p:nvPr/>
+        </p:nvSpPr>
+        <p:spPr>
+          <a:xfrm>
+            <a:off x="7596000" y="4150000"/>
+            <a:ext cx="2000000" cy="1100000"/>
+          </a:xfrm>
+          <a:prstGeom prst="roundRect">
+            <a:avLst>
+              <a:gd name="adj" fmla="val 12000"/>
+            </a:avLst>
+          </a:prstGeom>
+          <a:solidFill>
+            <a:srgbClr val="059669"/>
+          </a:solidFill>
+          <a:ln>
+            <a:noFill/>
+          </a:ln>
+        </p:spPr>
+        <p:txBody>
+          <a:bodyPr wrap="square" lIns="36000" tIns="36000" rIns="36000" bIns="36000" anchor="ctr"/>
+          <a:lstStyle/>
+          <a:p>
+            <a:pPr algn="ctr">
+              <a:lnSpc>
+                <a:spcPts val="2000"/>
+              </a:lnSpc>
+              <a:buNone/>
+            </a:pPr>
+            <a:r>
+              <a:rPr lang="en-US" sz="1800" b="1" dirty="0">
+                <a:solidFill>
+                  <a:srgbClr val="FFFFFF"/>
+                </a:solidFill>
+                <a:latin typeface="Segoe UI Semibold"/>
+              </a:rPr>
+              <a:t>Observe</a:t>
+            </a:r>
+          </a:p>
+          <a:p>
+            <a:pPr algn="ctr">
+              <a:lnSpc>
+                <a:spcPts val="1600"/>
+              </a:lnSpc>
+              <a:spcBef>
+                <a:spcPts val="100"/>
+              </a:spcBef>
+              <a:buNone/>
+            </a:pPr>
+            <a:r>
+              <a:rPr lang="en-US" sz="1200" dirty="0">
+                <a:solidFill>
+                  <a:srgbClr val="FFFFFF"/>
+                </a:solidFill>
+                <a:latin typeface="Segoe UI"/>
+              </a:rPr>
+              <a:t>output, errors, results</a:t>
+            </a:r>
+          </a:p>
+        </p:txBody>
+      </p:sp>
+      <p:sp>
+        <p:nvSpPr>
+          <p:cNvPr id="110" name="Arr1"/>
+          <p:cNvSpPr/>
+          <p:nvPr/>
+        </p:nvSpPr>
+        <p:spPr>
+          <a:xfrm>
+            <a:off x="4596000" y="2142500"/>
+            <a:ext cx="500000" cy="215000"/>
+          </a:xfrm>
+          <a:prstGeom prst="rightArrow">
+            <a:avLst>
+              <a:gd name="adj1" fmla="val 60000"/>
+              <a:gd name="adj2" fmla="val 50000"/>
+            </a:avLst>
+          </a:prstGeom>
+          <a:solidFill>
+            <a:srgbClr val="9CA3AF"/>
+          </a:solidFill>
+          <a:ln>
+            <a:noFill/>
+          </a:ln>
+        </p:spPr>
+        <p:txBody>
+          <a:bodyPr/>
+          <a:lstStyle/>
+          <a:p>
+            <a:endParaRPr lang="en-US"/>
+          </a:p>
+        </p:txBody>
+      </p:sp>
+      <p:sp>
+        <p:nvSpPr>
+          <p:cNvPr id="111" name="Arr2"/>
+          <p:cNvSpPr/>
+          <p:nvPr/>
+        </p:nvSpPr>
+        <p:spPr>
+          <a:xfrm>
+            <a:off x="7096000" y="2142500"/>
+            <a:ext cx="500000" cy="215000"/>
+          </a:xfrm>
+          <a:prstGeom prst="rightArrow">
+            <a:avLst>
+              <a:gd name="adj1" fmla="val 60000"/>
+              <a:gd name="adj2" fmla="val 50000"/>
+            </a:avLst>
+          </a:prstGeom>
+          <a:solidFill>
+            <a:srgbClr val="9CA3AF"/>
+          </a:solidFill>
+          <a:ln>
+            <a:noFill/>
+          </a:ln>
+        </p:spPr>
+        <p:txBody>
+          <a:bodyPr/>
+          <a:lstStyle/>
+          <a:p>
+            <a:endParaRPr lang="en-US"/>
+          </a:p>
+        </p:txBody>
+      </p:sp>
+      <p:sp>
+        <p:nvSpPr>
+          <p:cNvPr id="112" name="Arr3"/>
+          <p:cNvSpPr/>
+          <p:nvPr/>
+        </p:nvSpPr>
+        <p:spPr>
+          <a:xfrm>
+            <a:off x="8488500" y="2800000"/>
+            <a:ext cx="215000" cy="1350000"/>
+          </a:xfrm>
+          <a:prstGeom prst="downArrow">
+            <a:avLst>
+              <a:gd name="adj1" fmla="val 60000"/>
+              <a:gd name="adj2" fmla="val 50000"/>
+            </a:avLst>
+          </a:prstGeom>
+          <a:solidFill>
+            <a:srgbClr val="9CA3AF"/>
+          </a:solidFill>
+          <a:ln>
+            <a:noFill/>
+          </a:ln>
+        </p:spPr>
+        <p:txBody>
+          <a:bodyPr/>
+          <a:lstStyle/>
+          <a:p>
+            <a:endParaRPr lang="en-US"/>
+          </a:p>
+        </p:txBody>
+      </p:sp>
+      <p:sp>
+        <p:nvSpPr>
+          <p:cNvPr id="113" name="Arr4"/>
+          <p:cNvSpPr/>
+          <p:nvPr/>
+        </p:nvSpPr>
+        <p:spPr>
+          <a:xfrm>
+            <a:off x="4596000" y="4592500"/>
+            <a:ext cx="3000000" cy="215000"/>
+          </a:xfrm>
+          <a:prstGeom prst="leftArrow">
+            <a:avLst>
+              <a:gd name="adj1" fmla="val 60000"/>
+              <a:gd name="adj2" fmla="val 50000"/>
+            </a:avLst>
+          </a:prstGeom>
+          <a:solidFill>
+            <a:srgbClr val="9CA3AF"/>
+          </a:solidFill>
+          <a:ln>
+            <a:noFill/>
+          </a:ln>
+        </p:spPr>
+        <p:txBody>
+          <a:bodyPr/>
+          <a:lstStyle/>
+          <a:p>
+            <a:endParaRPr lang="en-US"/>
+          </a:p>
+        </p:txBody>
+      </p:sp>
+      <p:sp>
+        <p:nvSpPr>
+          <p:cNvPr id="114" name="Arr5"/>
+          <p:cNvSpPr/>
+          <p:nvPr/>
+        </p:nvSpPr>
+        <p:spPr>
+          <a:xfrm>
+            <a:off x="3488500" y="2800000"/>
+            <a:ext cx="215000" cy="1350000"/>
+          </a:xfrm>
+          <a:prstGeom prst="upArrow">
+            <a:avLst>
+              <a:gd name="adj1" fmla="val 60000"/>
+              <a:gd name="adj2" fmla="val 50000"/>
+            </a:avLst>
+          </a:prstGeom>
+          <a:solidFill>
+            <a:srgbClr val="9CA3AF"/>
+          </a:solidFill>
+          <a:ln>
+            <a:noFill/>
+          </a:ln>
+        </p:spPr>
+        <p:txBody>
+          <a:bodyPr/>
+          <a:lstStyle/>
+          <a:p>
+            <a:endParaRPr lang="en-US"/>
+          </a:p>
+        </p:txBody>
+      </p:sp>
+      <p:sp>
+        <p:nvSpPr>
+          <p:cNvPr id="120" name="RepeatLabel"/>
+          <p:cNvSpPr/>
+          <p:nvPr/>
+        </p:nvSpPr>
+        <p:spPr>
+          <a:xfrm>
+            <a:off x="4796000" y="4837500"/>
+            <a:ext cx="2600000" cy="300000"/>
+          </a:xfrm>
+          <a:prstGeom prst="rect">
+            <a:avLst/>
+          </a:prstGeom>
+          <a:noFill/>
+          <a:ln>
+            <a:noFill/>
+          </a:ln>
+        </p:spPr>
+        <p:txBody>
+          <a:bodyPr wrap="square" anchor="ctr"/>
+          <a:lstStyle/>
+          <a:p>
+            <a:pPr algn="ctr">
+              <a:buNone/>
+            </a:pPr>
+            <a:r>
+              <a:rPr lang="en-US" sz="1400" i="1" dirty="0">
+                <a:solidFill>
+                  <a:srgbClr val="4B5563"/>
+                </a:solidFill>
+                <a:latin typeface="Segoe UI"/>
+              </a:rPr>
+              <a:t>repeat until task complete</a:t>
+            </a:r>
+          </a:p>
+        </p:txBody>
+      </p:sp>
+      <p:sp>
+        <p:nvSpPr>
+          <p:cNvPr id="130" name="Step1"/>
+          <p:cNvSpPr/>
+          <p:nvPr/>
+        </p:nvSpPr>
+        <p:spPr>
+          <a:xfrm>
+            <a:off x="2596000" y="1330000"/>
+            <a:ext cx="330000" cy="330000"/>
+          </a:xfrm>
+          <a:prstGeom prst="ellipse">
+            <a:avLst/>
+          </a:prstGeom>
+          <a:solidFill>
+            <a:srgbClr val="2563EB">
+              <a:alpha val="20000"/>
+            </a:srgbClr>
+          </a:solidFill>
+          <a:ln>
+            <a:noFill/>
+          </a:ln>
+        </p:spPr>
+        <p:txBody>
+          <a:bodyPr wrap="none" lIns="0" tIns="0" rIns="0" bIns="0" anchor="ctr"/>
+          <a:lstStyle/>
+          <a:p>
+            <a:pPr algn="ctr">
+              <a:buNone/>
+            </a:pPr>
+            <a:r>
+              <a:rPr lang="en-US" sz="1400" b="1" dirty="0">
+                <a:solidFill>
+                  <a:srgbClr val="2563EB"/>
+                </a:solidFill>
+                <a:latin typeface="Segoe UI Semibold"/>
+              </a:rPr>
+              <a:t>1</a:t>
+            </a:r>
+          </a:p>
+        </p:txBody>
+      </p:sp>
+      <p:sp>
+        <p:nvSpPr>
+          <p:cNvPr id="131" name="Step2"/>
+          <p:cNvSpPr/>
+          <p:nvPr/>
+        </p:nvSpPr>
+        <p:spPr>
+          <a:xfrm>
+            <a:off x="5096000" y="1330000"/>
+            <a:ext cx="330000" cy="330000"/>
+          </a:xfrm>
+          <a:prstGeom prst="ellipse">
+            <a:avLst/>
+          </a:prstGeom>
+          <a:solidFill>
+            <a:srgbClr val="1A1A2E">
+              <a:alpha val="20000"/>
+            </a:srgbClr>
+          </a:solidFill>
+          <a:ln>
+            <a:noFill/>
+          </a:ln>
+        </p:spPr>
+        <p:txBody>
+          <a:bodyPr wrap="none" lIns="0" tIns="0" rIns="0" bIns="0" anchor="ctr"/>
+          <a:lstStyle/>
+          <a:p>
+            <a:pPr algn="ctr">
+              <a:buNone/>
+            </a:pPr>
+            <a:r>
+              <a:rPr lang="en-US" sz="1400" b="1" dirty="0">
+                <a:solidFill>
+                  <a:srgbClr val="1A1A2E"/>
+                </a:solidFill>
+                <a:latin typeface="Segoe UI Semibold"/>
+              </a:rPr>
+              <a:t>2</a:t>
+            </a:r>
+          </a:p>
+        </p:txBody>
+      </p:sp>
+      <p:sp>
+        <p:nvSpPr>
+          <p:cNvPr id="132" name="Step3"/>
+          <p:cNvSpPr/>
+          <p:nvPr/>
+        </p:nvSpPr>
+        <p:spPr>
+          <a:xfrm>
+            <a:off x="7596000" y="1330000"/>
+            <a:ext cx="330000" cy="330000"/>
+          </a:xfrm>
+          <a:prstGeom prst="ellipse">
+            <a:avLst/>
+          </a:prstGeom>
+          <a:solidFill>
+            <a:srgbClr val="D97706">
+              <a:alpha val="20000"/>
+            </a:srgbClr>
+          </a:solidFill>
+          <a:ln>
+            <a:noFill/>
+          </a:ln>
+        </p:spPr>
+        <p:txBody>
+          <a:bodyPr wrap="none" lIns="0" tIns="0" rIns="0" bIns="0" anchor="ctr"/>
+          <a:lstStyle/>
+          <a:p>
+            <a:pPr algn="ctr">
+              <a:buNone/>
+            </a:pPr>
+            <a:r>
+              <a:rPr lang="en-US" sz="1400" b="1" dirty="0">
+                <a:solidFill>
+                  <a:srgbClr val="D97706"/>
+                </a:solidFill>
+                <a:latin typeface="Segoe UI Semibold"/>
+              </a:rPr>
+              <a:t>3</a:t>
+            </a:r>
+          </a:p>
+        </p:txBody>
+      </p:sp>
+      <p:sp>
+        <p:nvSpPr>
+          <p:cNvPr id="133" name="Step4"/>
+          <p:cNvSpPr/>
+          <p:nvPr/>
+        </p:nvSpPr>
+        <p:spPr>
+          <a:xfrm>
+            <a:off x="7596000" y="3780000"/>
+            <a:ext cx="330000" cy="330000"/>
+          </a:xfrm>
+          <a:prstGeom prst="ellipse">
+            <a:avLst/>
+          </a:prstGeom>
+          <a:solidFill>
+            <a:srgbClr val="059669">
+              <a:alpha val="20000"/>
+            </a:srgbClr>
+          </a:solidFill>
+          <a:ln>
+            <a:noFill/>
+          </a:ln>
+        </p:spPr>
+        <p:txBody>
+          <a:bodyPr wrap="none" lIns="0" tIns="0" rIns="0" bIns="0" anchor="ctr"/>
+          <a:lstStyle/>
+          <a:p>
+            <a:pPr algn="ctr">
+              <a:buNone/>
+            </a:pPr>
+            <a:r>
+              <a:rPr lang="en-US" sz="1400" b="1" dirty="0">
+                <a:solidFill>
+                  <a:srgbClr val="059669"/>
+                </a:solidFill>
+                <a:latin typeface="Segoe UI Semibold"/>
+              </a:rPr>
+              <a:t>4</a:t>
+            </a:r>
+          </a:p>
+        </p:txBody>
+      </p:sp>
+    </p:spTree>
+    <p:extLst>
+      <p:ext uri="{BB962C8B-B14F-4D97-AF65-F5344CB8AC3E}">
+        <p14:creationId xmlns:p14="http://schemas.microsoft.com/office/powerpoint/2010/main" val="720377622"/>
       </p:ext>
     </p:extLst>
   </p:cSld>

</xml_diff>